<commit_message>
new file:   media_format/DigitalCommonwealth_CollectionDevelopmentPolicy_FINAL.pdf 	new file:   media_format/FADGITechnicalGuidelinesforDigitizingCulturalHeritageMaterials_ThirdEdition_05092023.pdf 	new file:   media_format/FAGDI_technical_guidelines_2023.pdf 	modified:   media_format/index.htm 	modified:   slideshow/CDashSlideshow_20240109.pptx 	modified:   stewardship/index.htm
</commit_message>
<xml_diff>
--- a/slideshow/CDashSlideshow_20240109.pptx
+++ b/slideshow/CDashSlideshow_20240109.pptx
@@ -33,9 +33,10 @@
     <p:sldId id="269" r:id="rId27"/>
     <p:sldId id="270" r:id="rId28"/>
     <p:sldId id="271" r:id="rId29"/>
-    <p:sldId id="272" r:id="rId30"/>
-    <p:sldId id="273" r:id="rId31"/>
-    <p:sldId id="257" r:id="rId32"/>
+    <p:sldId id="287" r:id="rId30"/>
+    <p:sldId id="272" r:id="rId31"/>
+    <p:sldId id="273" r:id="rId32"/>
+    <p:sldId id="257" r:id="rId33"/>
   </p:sldIdLst>
   <p:sldSz cx="12192000" cy="6858000"/>
   <p:notesSz cx="7772400" cy="10058400"/>
@@ -4812,7 +4813,7 @@
                 </a:solidFill>
                 <a:latin typeface="Calibri"/>
               </a:rPr>
-              <a:t>1/10/2024</a:t>
+              <a:t>3/26/2025</a:t>
             </a:fld>
             <a:endParaRPr lang="en-US" sz="1200" b="0" strike="noStrike" spc="-1">
               <a:latin typeface="Times New Roman"/>
@@ -5684,7 +5685,7 @@
                 </a:solidFill>
                 <a:latin typeface="Calibri"/>
               </a:rPr>
-              <a:t>1/10/2024</a:t>
+              <a:t>3/26/2025</a:t>
             </a:fld>
             <a:endParaRPr lang="en-US" sz="1200" b="0" strike="noStrike" spc="-1">
               <a:latin typeface="Times New Roman"/>
@@ -6182,7 +6183,7 @@
                 </a:solidFill>
                 <a:latin typeface="Calibri"/>
               </a:rPr>
-              <a:t>1/10/2024</a:t>
+              <a:t>3/26/2025</a:t>
             </a:fld>
             <a:endParaRPr lang="en-US" sz="1200" b="0" strike="noStrike" spc="-1">
               <a:latin typeface="Times New Roman"/>
@@ -7205,7 +7206,7 @@
                 </a:solidFill>
                 <a:latin typeface="Calibri"/>
               </a:rPr>
-              <a:t>1/10/2024</a:t>
+              <a:t>3/26/2025</a:t>
             </a:fld>
             <a:endParaRPr lang="en-US" sz="1200" b="0" strike="noStrike" spc="-1">
               <a:latin typeface="Times New Roman"/>
@@ -10532,7 +10533,7 @@
                 </a:solidFill>
                 <a:latin typeface="Calibri"/>
               </a:rPr>
-              <a:t>1/10/2024</a:t>
+              <a:t>3/26/2025</a:t>
             </a:fld>
             <a:endParaRPr lang="en-US" sz="1200" b="0" strike="noStrike" spc="-1">
               <a:latin typeface="Times New Roman"/>
@@ -13255,7 +13256,7 @@
                 </a:solidFill>
                 <a:latin typeface="Calibri"/>
               </a:rPr>
-              <a:t>1/10/2024</a:t>
+              <a:t>3/26/2025</a:t>
             </a:fld>
             <a:endParaRPr lang="en-US" sz="1200" b="0" strike="noStrike" spc="-1">
               <a:latin typeface="Times New Roman"/>
@@ -14494,7 +14495,7 @@
                 </a:solidFill>
                 <a:latin typeface="Calibri"/>
               </a:rPr>
-              <a:t>1/10/2024</a:t>
+              <a:t>3/26/2025</a:t>
             </a:fld>
             <a:endParaRPr lang="en-US" sz="1200" b="0" strike="noStrike" spc="-1">
               <a:latin typeface="Times New Roman"/>
@@ -15361,7 +15362,7 @@
                 </a:solidFill>
                 <a:latin typeface="Calibri"/>
               </a:rPr>
-              <a:t>1/10/2024</a:t>
+              <a:t>3/26/2025</a:t>
             </a:fld>
             <a:endParaRPr lang="en-US" sz="1200" b="0" strike="noStrike" spc="-1">
               <a:latin typeface="Times New Roman"/>
@@ -17172,7 +17173,7 @@
                 </a:solidFill>
                 <a:latin typeface="Calibri"/>
               </a:rPr>
-              <a:t>1/10/2024</a:t>
+              <a:t>3/26/2025</a:t>
             </a:fld>
             <a:endParaRPr lang="en-US" sz="1200" b="0" strike="noStrike" spc="-1">
               <a:latin typeface="Times New Roman"/>
@@ -19125,7 +19126,7 @@
                 </a:solidFill>
                 <a:latin typeface="Calibri"/>
               </a:rPr>
-              <a:t>1/10/2024</a:t>
+              <a:t>3/26/2025</a:t>
             </a:fld>
             <a:endParaRPr lang="en-US" sz="1200" b="0" strike="noStrike" spc="-1">
               <a:latin typeface="Times New Roman"/>
@@ -24400,7 +24401,7 @@
                 </a:solidFill>
                 <a:latin typeface="Calibri"/>
               </a:rPr>
-              <a:t>1/10/2024</a:t>
+              <a:t>3/26/2025</a:t>
             </a:fld>
             <a:endParaRPr lang="en-US" sz="1200" b="0" strike="noStrike" spc="-1">
               <a:latin typeface="Times New Roman"/>
@@ -24478,6 +24479,36 @@
           <a:chExt cx="0" cy="0"/>
         </a:xfrm>
       </p:grpSpPr>
+    </p:spTree>
+    <p:extLst>
+      <p:ext uri="{BB962C8B-B14F-4D97-AF65-F5344CB8AC3E}">
+        <p14:creationId xmlns:p14="http://schemas.microsoft.com/office/powerpoint/2010/main" val="710290935"/>
+      </p:ext>
+    </p:extLst>
+  </p:cSld>
+  <p:clrMapOvr>
+    <a:masterClrMapping/>
+  </p:clrMapOvr>
+</p:sld>
+</file>
+
+<file path=ppt/slides/slide28.xml><?xml version="1.0" encoding="utf-8"?>
+<p:sld xmlns:a="http://schemas.openxmlformats.org/drawingml/2006/main" xmlns:r="http://schemas.openxmlformats.org/officeDocument/2006/relationships" xmlns:p="http://schemas.openxmlformats.org/presentationml/2006/main">
+  <p:cSld>
+    <p:spTree>
+      <p:nvGrpSpPr>
+        <p:cNvPr id="1" name=""/>
+        <p:cNvGrpSpPr/>
+        <p:nvPr/>
+      </p:nvGrpSpPr>
+      <p:grpSpPr>
+        <a:xfrm>
+          <a:off x="0" y="0"/>
+          <a:ext cx="0" cy="0"/>
+          <a:chOff x="0" y="0"/>
+          <a:chExt cx="0" cy="0"/>
+        </a:xfrm>
+      </p:grpSpPr>
       <p:sp>
         <p:nvSpPr>
           <p:cNvPr id="428" name="CustomShape 1"/>
@@ -24960,7 +24991,7 @@
                 </a:solidFill>
                 <a:latin typeface="Calibri"/>
               </a:rPr>
-              <a:t>1/10/2024</a:t>
+              <a:t>3/26/2025</a:t>
             </a:fld>
             <a:endParaRPr lang="en-US" sz="1200" b="0" strike="noStrike" spc="-1">
               <a:latin typeface="Times New Roman"/>
@@ -25005,7 +25036,7 @@
                 </a:solidFill>
                 <a:latin typeface="Calibri"/>
               </a:rPr>
-              <a:t>27</a:t>
+              <a:t>28</a:t>
             </a:fld>
             <a:endParaRPr lang="en-US" sz="1200" b="0" strike="noStrike" spc="-1">
               <a:latin typeface="Times New Roman"/>
@@ -25021,7 +25052,7 @@
 </p:sld>
 </file>
 
-<file path=ppt/slides/slide28.xml><?xml version="1.0" encoding="utf-8"?>
+<file path=ppt/slides/slide29.xml><?xml version="1.0" encoding="utf-8"?>
 <p:sld xmlns:a="http://schemas.openxmlformats.org/drawingml/2006/main" xmlns:r="http://schemas.openxmlformats.org/officeDocument/2006/relationships" xmlns:p="http://schemas.openxmlformats.org/presentationml/2006/main" show="0">
   <p:cSld>
     <p:spTree>
@@ -25747,7 +25778,7 @@
                 </a:solidFill>
                 <a:latin typeface="Calibri"/>
               </a:rPr>
-              <a:t>1/10/2024</a:t>
+              <a:t>3/26/2025</a:t>
             </a:fld>
             <a:endParaRPr lang="en-US" sz="1200" b="0" strike="noStrike" spc="-1">
               <a:latin typeface="Times New Roman"/>
@@ -25786,438 +25817,6 @@
               </a:lnSpc>
             </a:pPr>
             <a:fld id="{EC2B1968-1C23-404F-8BF5-9D334DF69902}" type="slidenum">
-              <a:rPr lang="en-US" sz="1200" b="0" strike="noStrike" spc="-1">
-                <a:solidFill>
-                  <a:srgbClr val="8B8B8B"/>
-                </a:solidFill>
-                <a:latin typeface="Calibri"/>
-              </a:rPr>
-              <a:t>28</a:t>
-            </a:fld>
-            <a:endParaRPr lang="en-US" sz="1200" b="0" strike="noStrike" spc="-1">
-              <a:latin typeface="Times New Roman"/>
-            </a:endParaRPr>
-          </a:p>
-        </p:txBody>
-      </p:sp>
-    </p:spTree>
-  </p:cSld>
-  <p:clrMapOvr>
-    <a:masterClrMapping/>
-  </p:clrMapOvr>
-</p:sld>
-</file>
-
-<file path=ppt/slides/slide29.xml><?xml version="1.0" encoding="utf-8"?>
-<p:sld xmlns:a="http://schemas.openxmlformats.org/drawingml/2006/main" xmlns:r="http://schemas.openxmlformats.org/officeDocument/2006/relationships" xmlns:p="http://schemas.openxmlformats.org/presentationml/2006/main">
-  <p:cSld>
-    <p:spTree>
-      <p:nvGrpSpPr>
-        <p:cNvPr id="1" name=""/>
-        <p:cNvGrpSpPr/>
-        <p:nvPr/>
-      </p:nvGrpSpPr>
-      <p:grpSpPr>
-        <a:xfrm>
-          <a:off x="0" y="0"/>
-          <a:ext cx="0" cy="0"/>
-          <a:chOff x="0" y="0"/>
-          <a:chExt cx="0" cy="0"/>
-        </a:xfrm>
-      </p:grpSpPr>
-      <p:sp>
-        <p:nvSpPr>
-          <p:cNvPr id="137" name="TextShape 1"/>
-          <p:cNvSpPr txBox="1"/>
-          <p:nvPr/>
-        </p:nvSpPr>
-        <p:spPr>
-          <a:xfrm>
-            <a:off x="838080" y="1116360"/>
-            <a:ext cx="10515240" cy="5394600"/>
-          </a:xfrm>
-          <a:prstGeom prst="rect">
-            <a:avLst/>
-          </a:prstGeom>
-          <a:noFill/>
-          <a:ln>
-            <a:noFill/>
-          </a:ln>
-        </p:spPr>
-        <p:txBody>
-          <a:bodyPr>
-            <a:normAutofit lnSpcReduction="10000"/>
-          </a:bodyPr>
-          <a:lstStyle/>
-          <a:p>
-            <a:pPr>
-              <a:lnSpc>
-                <a:spcPct val="90000"/>
-              </a:lnSpc>
-              <a:spcBef>
-                <a:spcPts val="1001"/>
-              </a:spcBef>
-            </a:pPr>
-            <a:r>
-              <a:rPr lang="en-US" sz="2800" b="0" strike="noStrike" spc="-1">
-                <a:solidFill>
-                  <a:srgbClr val="000000"/>
-                </a:solidFill>
-                <a:latin typeface="Calibri"/>
-              </a:rPr>
-              <a:t>These references provide some background on how to organize a digitizing project.</a:t>
-            </a:r>
-          </a:p>
-          <a:p>
-            <a:pPr marL="228600" indent="-228240">
-              <a:lnSpc>
-                <a:spcPct val="90000"/>
-              </a:lnSpc>
-              <a:spcBef>
-                <a:spcPts val="1001"/>
-              </a:spcBef>
-              <a:buClr>
-                <a:srgbClr val="000000"/>
-              </a:buClr>
-              <a:buFont typeface="Arial"/>
-              <a:buChar char="•"/>
-            </a:pPr>
-            <a:r>
-              <a:rPr lang="en-US" sz="2400" b="0" strike="noStrike" spc="-1">
-                <a:solidFill>
-                  <a:srgbClr val="000000"/>
-                </a:solidFill>
-                <a:latin typeface="Calibri"/>
-              </a:rPr>
-              <a:t>Digital Public Library of America</a:t>
-            </a:r>
-            <a:br/>
-            <a:r>
-              <a:rPr lang="en-US" sz="2400" b="1" strike="noStrike" spc="-1">
-                <a:solidFill>
-                  <a:srgbClr val="808080"/>
-                </a:solidFill>
-                <a:latin typeface="Calibri"/>
-              </a:rPr>
-              <a:t>Digital Reformatting and File Management</a:t>
-            </a:r>
-            <a:br/>
-            <a:r>
-              <a:rPr lang="en-US" sz="1600" b="0" u="sng" strike="noStrike" spc="-1">
-                <a:solidFill>
-                  <a:srgbClr val="0563C1"/>
-                </a:solidFill>
-                <a:uFillTx/>
-                <a:latin typeface="Calibri"/>
-                <a:hlinkClick r:id="rId2"/>
-              </a:rPr>
-              <a:t>http://dp.la/info/about/projects/public-library-partnerships/digital-reformatting-and-file-management/</a:t>
-            </a:r>
-            <a:endParaRPr lang="en-US" sz="1600" b="0" strike="noStrike" spc="-1">
-              <a:solidFill>
-                <a:srgbClr val="000000"/>
-              </a:solidFill>
-              <a:latin typeface="Calibri"/>
-            </a:endParaRPr>
-          </a:p>
-          <a:p>
-            <a:pPr marL="228600" indent="-228240">
-              <a:lnSpc>
-                <a:spcPct val="90000"/>
-              </a:lnSpc>
-              <a:spcBef>
-                <a:spcPts val="1001"/>
-              </a:spcBef>
-              <a:buClr>
-                <a:srgbClr val="000000"/>
-              </a:buClr>
-              <a:buFont typeface="Arial"/>
-              <a:buChar char="•"/>
-            </a:pPr>
-            <a:r>
-              <a:rPr lang="en-US" sz="2400" b="0" strike="noStrike" spc="-1">
-                <a:solidFill>
-                  <a:srgbClr val="000000"/>
-                </a:solidFill>
-                <a:latin typeface="Calibri"/>
-              </a:rPr>
-              <a:t>National Archives:</a:t>
-            </a:r>
-            <a:br/>
-            <a:r>
-              <a:rPr lang="en-US" sz="2400" b="1" strike="noStrike" spc="-1">
-                <a:solidFill>
-                  <a:srgbClr val="808080"/>
-                </a:solidFill>
-                <a:latin typeface="Calibri"/>
-              </a:rPr>
-              <a:t>Technical Guidelines for Digitizing Archival Materials for Electronic Access: Creation of Production Master Files – Raster Images</a:t>
-            </a:r>
-            <a:br/>
-            <a:r>
-              <a:rPr lang="en-US" sz="1600" b="0" u="sng" strike="noStrike" spc="-1">
-                <a:solidFill>
-                  <a:srgbClr val="0563C1"/>
-                </a:solidFill>
-                <a:uFillTx/>
-                <a:latin typeface="Calibri"/>
-                <a:hlinkClick r:id="rId3"/>
-              </a:rPr>
-              <a:t>https://www.archives.gov/files/preservation/technical/guidelines.pdf</a:t>
-            </a:r>
-            <a:endParaRPr lang="en-US" sz="1600" b="0" strike="noStrike" spc="-1">
-              <a:solidFill>
-                <a:srgbClr val="000000"/>
-              </a:solidFill>
-              <a:latin typeface="Calibri"/>
-            </a:endParaRPr>
-          </a:p>
-          <a:p>
-            <a:pPr marL="228600" indent="-228240">
-              <a:lnSpc>
-                <a:spcPct val="90000"/>
-              </a:lnSpc>
-              <a:spcBef>
-                <a:spcPts val="1001"/>
-              </a:spcBef>
-              <a:buClr>
-                <a:srgbClr val="000000"/>
-              </a:buClr>
-              <a:buFont typeface="Arial"/>
-              <a:buChar char="•"/>
-            </a:pPr>
-            <a:r>
-              <a:rPr lang="en-US" sz="2400" b="0" strike="noStrike" spc="-1">
-                <a:solidFill>
-                  <a:srgbClr val="000000"/>
-                </a:solidFill>
-                <a:latin typeface="Calibri"/>
-              </a:rPr>
-              <a:t>Smithsonian Institution</a:t>
-            </a:r>
-            <a:br/>
-            <a:r>
-              <a:rPr lang="en-US" sz="2400" b="1" strike="noStrike" spc="-1">
-                <a:solidFill>
-                  <a:srgbClr val="808080"/>
-                </a:solidFill>
-                <a:latin typeface="Calibri"/>
-              </a:rPr>
-              <a:t>Digitizing Collections</a:t>
-            </a:r>
-            <a:br/>
-            <a:r>
-              <a:rPr lang="en-US" sz="1600" b="0" u="sng" strike="noStrike" spc="-1">
-                <a:solidFill>
-                  <a:srgbClr val="0563C1"/>
-                </a:solidFill>
-                <a:uFillTx/>
-                <a:latin typeface="Calibri"/>
-                <a:hlinkClick r:id="rId4"/>
-              </a:rPr>
-              <a:t>https://siarchives.si.edu/what-we-do/digital-curation/digitizing-collections</a:t>
-            </a:r>
-            <a:endParaRPr lang="en-US" sz="1600" b="0" strike="noStrike" spc="-1">
-              <a:solidFill>
-                <a:srgbClr val="000000"/>
-              </a:solidFill>
-              <a:latin typeface="Calibri"/>
-            </a:endParaRPr>
-          </a:p>
-          <a:p>
-            <a:pPr marL="228600" indent="-228240">
-              <a:lnSpc>
-                <a:spcPct val="90000"/>
-              </a:lnSpc>
-              <a:spcBef>
-                <a:spcPts val="1001"/>
-              </a:spcBef>
-              <a:buClr>
-                <a:srgbClr val="000000"/>
-              </a:buClr>
-              <a:buFont typeface="Arial"/>
-              <a:buChar char="•"/>
-            </a:pPr>
-            <a:r>
-              <a:rPr lang="en-US" sz="2400" b="0" strike="noStrike" spc="-1">
-                <a:solidFill>
-                  <a:srgbClr val="000000"/>
-                </a:solidFill>
-                <a:latin typeface="Calibri"/>
-              </a:rPr>
-              <a:t>Open Archive Initiative</a:t>
-            </a:r>
-            <a:br/>
-            <a:r>
-              <a:rPr lang="en-US" sz="2400" b="1" strike="noStrike" spc="-1">
-                <a:solidFill>
-                  <a:srgbClr val="808080"/>
-                </a:solidFill>
-                <a:latin typeface="Calibri"/>
-              </a:rPr>
-              <a:t>Standards for Web Content Interoperability</a:t>
-            </a:r>
-            <a:br/>
-            <a:r>
-              <a:rPr lang="en-US" sz="1600" b="0" u="sng" strike="noStrike" spc="-1">
-                <a:solidFill>
-                  <a:srgbClr val="0563C1"/>
-                </a:solidFill>
-                <a:uFillTx/>
-                <a:latin typeface="Calibri"/>
-                <a:hlinkClick r:id="rId5"/>
-              </a:rPr>
-              <a:t>https://openarchives.org/</a:t>
-            </a:r>
-            <a:br/>
-            <a:r>
-              <a:rPr lang="en-US" sz="1600" b="0" strike="noStrike" spc="-1">
-                <a:solidFill>
-                  <a:srgbClr val="000000"/>
-                </a:solidFill>
-                <a:latin typeface="Calibri"/>
-              </a:rPr>
-              <a:t> </a:t>
-            </a:r>
-          </a:p>
-        </p:txBody>
-      </p:sp>
-      <p:sp>
-        <p:nvSpPr>
-          <p:cNvPr id="138" name="CustomShape 2"/>
-          <p:cNvSpPr/>
-          <p:nvPr/>
-        </p:nvSpPr>
-        <p:spPr>
-          <a:xfrm>
-            <a:off x="838080" y="346680"/>
-            <a:ext cx="3970800" cy="760680"/>
-          </a:xfrm>
-          <a:prstGeom prst="rect">
-            <a:avLst/>
-          </a:prstGeom>
-          <a:noFill/>
-          <a:ln>
-            <a:noFill/>
-          </a:ln>
-        </p:spPr>
-        <p:style>
-          <a:lnRef idx="0">
-            <a:scrgbClr r="0" g="0" b="0"/>
-          </a:lnRef>
-          <a:fillRef idx="0">
-            <a:scrgbClr r="0" g="0" b="0"/>
-          </a:fillRef>
-          <a:effectRef idx="0">
-            <a:scrgbClr r="0" g="0" b="0"/>
-          </a:effectRef>
-          <a:fontRef idx="minor"/>
-        </p:style>
-        <p:txBody>
-          <a:bodyPr lIns="90000" tIns="45000" rIns="90000" bIns="45000">
-            <a:spAutoFit/>
-          </a:bodyPr>
-          <a:lstStyle/>
-          <a:p>
-            <a:pPr marL="285840" indent="-285480">
-              <a:lnSpc>
-                <a:spcPct val="100000"/>
-              </a:lnSpc>
-            </a:pPr>
-            <a:r>
-              <a:rPr lang="en-US" sz="4400" b="1" strike="noStrike" spc="-1">
-                <a:solidFill>
-                  <a:srgbClr val="2E75B6"/>
-                </a:solidFill>
-                <a:latin typeface="Calibri"/>
-              </a:rPr>
-              <a:t>Resources</a:t>
-            </a:r>
-            <a:endParaRPr lang="en-US" sz="4400" b="0" strike="noStrike" spc="-1">
-              <a:solidFill>
-                <a:srgbClr val="000000"/>
-              </a:solidFill>
-              <a:latin typeface="Arial"/>
-            </a:endParaRPr>
-          </a:p>
-        </p:txBody>
-      </p:sp>
-      <p:sp>
-        <p:nvSpPr>
-          <p:cNvPr id="139" name="TextShape 3"/>
-          <p:cNvSpPr txBox="1"/>
-          <p:nvPr/>
-        </p:nvSpPr>
-        <p:spPr>
-          <a:xfrm>
-            <a:off x="5678640" y="6409800"/>
-            <a:ext cx="1375200" cy="364680"/>
-          </a:xfrm>
-          <a:prstGeom prst="rect">
-            <a:avLst/>
-          </a:prstGeom>
-          <a:noFill/>
-          <a:ln>
-            <a:noFill/>
-          </a:ln>
-        </p:spPr>
-        <p:txBody>
-          <a:bodyPr anchor="ctr">
-            <a:noAutofit/>
-          </a:bodyPr>
-          <a:lstStyle/>
-          <a:p>
-            <a:pPr>
-              <a:lnSpc>
-                <a:spcPct val="100000"/>
-              </a:lnSpc>
-            </a:pPr>
-            <a:fld id="{96DF9C7D-5E38-486E-8788-46E53B4540D2}" type="datetime1">
-              <a:rPr lang="en-US" sz="1200" b="0" strike="noStrike" spc="-1">
-                <a:solidFill>
-                  <a:srgbClr val="8B8B8B"/>
-                </a:solidFill>
-                <a:latin typeface="Calibri"/>
-              </a:rPr>
-              <a:t>1/10/2024</a:t>
-            </a:fld>
-            <a:endParaRPr lang="en-US" sz="1200" b="0" strike="noStrike" spc="-1">
-              <a:latin typeface="Times New Roman"/>
-            </a:endParaRPr>
-          </a:p>
-        </p:txBody>
-      </p:sp>
-      <p:sp>
-        <p:nvSpPr>
-          <p:cNvPr id="140" name="TextShape 4"/>
-          <p:cNvSpPr txBox="1"/>
-          <p:nvPr/>
-        </p:nvSpPr>
-        <p:spPr>
-          <a:xfrm>
-            <a:off x="838080" y="6396480"/>
-            <a:ext cx="964440" cy="364680"/>
-          </a:xfrm>
-          <a:prstGeom prst="rect">
-            <a:avLst/>
-          </a:prstGeom>
-          <a:noFill/>
-          <a:ln>
-            <a:noFill/>
-          </a:ln>
-        </p:spPr>
-        <p:txBody>
-          <a:bodyPr anchor="ctr">
-            <a:noAutofit/>
-          </a:bodyPr>
-          <a:lstStyle/>
-          <a:p>
-            <a:pPr>
-              <a:lnSpc>
-                <a:spcPct val="100000"/>
-              </a:lnSpc>
-            </a:pPr>
-            <a:fld id="{DDC9E873-F36C-4741-A928-0EF646AA7E33}" type="slidenum">
               <a:rPr lang="en-US" sz="1200" b="0" strike="noStrike" spc="-1">
                 <a:solidFill>
                   <a:srgbClr val="8B8B8B"/>
@@ -26537,7 +26136,7 @@
                 </a:solidFill>
                 <a:latin typeface="Calibri"/>
               </a:rPr>
-              <a:t>1/10/2024</a:t>
+              <a:t>3/26/2025</a:t>
             </a:fld>
             <a:endParaRPr lang="en-US" sz="1200" b="0" strike="noStrike" spc="-1">
               <a:latin typeface="Times New Roman"/>
@@ -27270,6 +26869,438 @@
 </p:sld>
 </file>
 
+<file path=ppt/slides/slide30.xml><?xml version="1.0" encoding="utf-8"?>
+<p:sld xmlns:a="http://schemas.openxmlformats.org/drawingml/2006/main" xmlns:r="http://schemas.openxmlformats.org/officeDocument/2006/relationships" xmlns:p="http://schemas.openxmlformats.org/presentationml/2006/main">
+  <p:cSld>
+    <p:spTree>
+      <p:nvGrpSpPr>
+        <p:cNvPr id="1" name=""/>
+        <p:cNvGrpSpPr/>
+        <p:nvPr/>
+      </p:nvGrpSpPr>
+      <p:grpSpPr>
+        <a:xfrm>
+          <a:off x="0" y="0"/>
+          <a:ext cx="0" cy="0"/>
+          <a:chOff x="0" y="0"/>
+          <a:chExt cx="0" cy="0"/>
+        </a:xfrm>
+      </p:grpSpPr>
+      <p:sp>
+        <p:nvSpPr>
+          <p:cNvPr id="137" name="TextShape 1"/>
+          <p:cNvSpPr txBox="1"/>
+          <p:nvPr/>
+        </p:nvSpPr>
+        <p:spPr>
+          <a:xfrm>
+            <a:off x="838080" y="1116360"/>
+            <a:ext cx="10515240" cy="5394600"/>
+          </a:xfrm>
+          <a:prstGeom prst="rect">
+            <a:avLst/>
+          </a:prstGeom>
+          <a:noFill/>
+          <a:ln>
+            <a:noFill/>
+          </a:ln>
+        </p:spPr>
+        <p:txBody>
+          <a:bodyPr>
+            <a:normAutofit lnSpcReduction="10000"/>
+          </a:bodyPr>
+          <a:lstStyle/>
+          <a:p>
+            <a:pPr>
+              <a:lnSpc>
+                <a:spcPct val="90000"/>
+              </a:lnSpc>
+              <a:spcBef>
+                <a:spcPts val="1001"/>
+              </a:spcBef>
+            </a:pPr>
+            <a:r>
+              <a:rPr lang="en-US" sz="2800" b="0" strike="noStrike" spc="-1">
+                <a:solidFill>
+                  <a:srgbClr val="000000"/>
+                </a:solidFill>
+                <a:latin typeface="Calibri"/>
+              </a:rPr>
+              <a:t>These references provide some background on how to organize a digitizing project.</a:t>
+            </a:r>
+          </a:p>
+          <a:p>
+            <a:pPr marL="228600" indent="-228240">
+              <a:lnSpc>
+                <a:spcPct val="90000"/>
+              </a:lnSpc>
+              <a:spcBef>
+                <a:spcPts val="1001"/>
+              </a:spcBef>
+              <a:buClr>
+                <a:srgbClr val="000000"/>
+              </a:buClr>
+              <a:buFont typeface="Arial"/>
+              <a:buChar char="•"/>
+            </a:pPr>
+            <a:r>
+              <a:rPr lang="en-US" sz="2400" b="0" strike="noStrike" spc="-1">
+                <a:solidFill>
+                  <a:srgbClr val="000000"/>
+                </a:solidFill>
+                <a:latin typeface="Calibri"/>
+              </a:rPr>
+              <a:t>Digital Public Library of America</a:t>
+            </a:r>
+            <a:br/>
+            <a:r>
+              <a:rPr lang="en-US" sz="2400" b="1" strike="noStrike" spc="-1">
+                <a:solidFill>
+                  <a:srgbClr val="808080"/>
+                </a:solidFill>
+                <a:latin typeface="Calibri"/>
+              </a:rPr>
+              <a:t>Digital Reformatting and File Management</a:t>
+            </a:r>
+            <a:br/>
+            <a:r>
+              <a:rPr lang="en-US" sz="1600" b="0" u="sng" strike="noStrike" spc="-1">
+                <a:solidFill>
+                  <a:srgbClr val="0563C1"/>
+                </a:solidFill>
+                <a:uFillTx/>
+                <a:latin typeface="Calibri"/>
+                <a:hlinkClick r:id="rId2"/>
+              </a:rPr>
+              <a:t>http://dp.la/info/about/projects/public-library-partnerships/digital-reformatting-and-file-management/</a:t>
+            </a:r>
+            <a:endParaRPr lang="en-US" sz="1600" b="0" strike="noStrike" spc="-1">
+              <a:solidFill>
+                <a:srgbClr val="000000"/>
+              </a:solidFill>
+              <a:latin typeface="Calibri"/>
+            </a:endParaRPr>
+          </a:p>
+          <a:p>
+            <a:pPr marL="228600" indent="-228240">
+              <a:lnSpc>
+                <a:spcPct val="90000"/>
+              </a:lnSpc>
+              <a:spcBef>
+                <a:spcPts val="1001"/>
+              </a:spcBef>
+              <a:buClr>
+                <a:srgbClr val="000000"/>
+              </a:buClr>
+              <a:buFont typeface="Arial"/>
+              <a:buChar char="•"/>
+            </a:pPr>
+            <a:r>
+              <a:rPr lang="en-US" sz="2400" b="0" strike="noStrike" spc="-1">
+                <a:solidFill>
+                  <a:srgbClr val="000000"/>
+                </a:solidFill>
+                <a:latin typeface="Calibri"/>
+              </a:rPr>
+              <a:t>National Archives:</a:t>
+            </a:r>
+            <a:br/>
+            <a:r>
+              <a:rPr lang="en-US" sz="2400" b="1" strike="noStrike" spc="-1">
+                <a:solidFill>
+                  <a:srgbClr val="808080"/>
+                </a:solidFill>
+                <a:latin typeface="Calibri"/>
+              </a:rPr>
+              <a:t>Technical Guidelines for Digitizing Archival Materials for Electronic Access: Creation of Production Master Files – Raster Images</a:t>
+            </a:r>
+            <a:br/>
+            <a:r>
+              <a:rPr lang="en-US" sz="1600" b="0" u="sng" strike="noStrike" spc="-1">
+                <a:solidFill>
+                  <a:srgbClr val="0563C1"/>
+                </a:solidFill>
+                <a:uFillTx/>
+                <a:latin typeface="Calibri"/>
+                <a:hlinkClick r:id="rId3"/>
+              </a:rPr>
+              <a:t>https://www.archives.gov/files/preservation/technical/guidelines.pdf</a:t>
+            </a:r>
+            <a:endParaRPr lang="en-US" sz="1600" b="0" strike="noStrike" spc="-1">
+              <a:solidFill>
+                <a:srgbClr val="000000"/>
+              </a:solidFill>
+              <a:latin typeface="Calibri"/>
+            </a:endParaRPr>
+          </a:p>
+          <a:p>
+            <a:pPr marL="228600" indent="-228240">
+              <a:lnSpc>
+                <a:spcPct val="90000"/>
+              </a:lnSpc>
+              <a:spcBef>
+                <a:spcPts val="1001"/>
+              </a:spcBef>
+              <a:buClr>
+                <a:srgbClr val="000000"/>
+              </a:buClr>
+              <a:buFont typeface="Arial"/>
+              <a:buChar char="•"/>
+            </a:pPr>
+            <a:r>
+              <a:rPr lang="en-US" sz="2400" b="0" strike="noStrike" spc="-1">
+                <a:solidFill>
+                  <a:srgbClr val="000000"/>
+                </a:solidFill>
+                <a:latin typeface="Calibri"/>
+              </a:rPr>
+              <a:t>Smithsonian Institution</a:t>
+            </a:r>
+            <a:br/>
+            <a:r>
+              <a:rPr lang="en-US" sz="2400" b="1" strike="noStrike" spc="-1">
+                <a:solidFill>
+                  <a:srgbClr val="808080"/>
+                </a:solidFill>
+                <a:latin typeface="Calibri"/>
+              </a:rPr>
+              <a:t>Digitizing Collections</a:t>
+            </a:r>
+            <a:br/>
+            <a:r>
+              <a:rPr lang="en-US" sz="1600" b="0" u="sng" strike="noStrike" spc="-1">
+                <a:solidFill>
+                  <a:srgbClr val="0563C1"/>
+                </a:solidFill>
+                <a:uFillTx/>
+                <a:latin typeface="Calibri"/>
+                <a:hlinkClick r:id="rId4"/>
+              </a:rPr>
+              <a:t>https://siarchives.si.edu/what-we-do/digital-curation/digitizing-collections</a:t>
+            </a:r>
+            <a:endParaRPr lang="en-US" sz="1600" b="0" strike="noStrike" spc="-1">
+              <a:solidFill>
+                <a:srgbClr val="000000"/>
+              </a:solidFill>
+              <a:latin typeface="Calibri"/>
+            </a:endParaRPr>
+          </a:p>
+          <a:p>
+            <a:pPr marL="228600" indent="-228240">
+              <a:lnSpc>
+                <a:spcPct val="90000"/>
+              </a:lnSpc>
+              <a:spcBef>
+                <a:spcPts val="1001"/>
+              </a:spcBef>
+              <a:buClr>
+                <a:srgbClr val="000000"/>
+              </a:buClr>
+              <a:buFont typeface="Arial"/>
+              <a:buChar char="•"/>
+            </a:pPr>
+            <a:r>
+              <a:rPr lang="en-US" sz="2400" b="0" strike="noStrike" spc="-1">
+                <a:solidFill>
+                  <a:srgbClr val="000000"/>
+                </a:solidFill>
+                <a:latin typeface="Calibri"/>
+              </a:rPr>
+              <a:t>Open Archive Initiative</a:t>
+            </a:r>
+            <a:br/>
+            <a:r>
+              <a:rPr lang="en-US" sz="2400" b="1" strike="noStrike" spc="-1">
+                <a:solidFill>
+                  <a:srgbClr val="808080"/>
+                </a:solidFill>
+                <a:latin typeface="Calibri"/>
+              </a:rPr>
+              <a:t>Standards for Web Content Interoperability</a:t>
+            </a:r>
+            <a:br/>
+            <a:r>
+              <a:rPr lang="en-US" sz="1600" b="0" u="sng" strike="noStrike" spc="-1">
+                <a:solidFill>
+                  <a:srgbClr val="0563C1"/>
+                </a:solidFill>
+                <a:uFillTx/>
+                <a:latin typeface="Calibri"/>
+                <a:hlinkClick r:id="rId5"/>
+              </a:rPr>
+              <a:t>https://openarchives.org/</a:t>
+            </a:r>
+            <a:br/>
+            <a:r>
+              <a:rPr lang="en-US" sz="1600" b="0" strike="noStrike" spc="-1">
+                <a:solidFill>
+                  <a:srgbClr val="000000"/>
+                </a:solidFill>
+                <a:latin typeface="Calibri"/>
+              </a:rPr>
+              <a:t> </a:t>
+            </a:r>
+          </a:p>
+        </p:txBody>
+      </p:sp>
+      <p:sp>
+        <p:nvSpPr>
+          <p:cNvPr id="138" name="CustomShape 2"/>
+          <p:cNvSpPr/>
+          <p:nvPr/>
+        </p:nvSpPr>
+        <p:spPr>
+          <a:xfrm>
+            <a:off x="838080" y="346680"/>
+            <a:ext cx="3970800" cy="760680"/>
+          </a:xfrm>
+          <a:prstGeom prst="rect">
+            <a:avLst/>
+          </a:prstGeom>
+          <a:noFill/>
+          <a:ln>
+            <a:noFill/>
+          </a:ln>
+        </p:spPr>
+        <p:style>
+          <a:lnRef idx="0">
+            <a:scrgbClr r="0" g="0" b="0"/>
+          </a:lnRef>
+          <a:fillRef idx="0">
+            <a:scrgbClr r="0" g="0" b="0"/>
+          </a:fillRef>
+          <a:effectRef idx="0">
+            <a:scrgbClr r="0" g="0" b="0"/>
+          </a:effectRef>
+          <a:fontRef idx="minor"/>
+        </p:style>
+        <p:txBody>
+          <a:bodyPr lIns="90000" tIns="45000" rIns="90000" bIns="45000">
+            <a:spAutoFit/>
+          </a:bodyPr>
+          <a:lstStyle/>
+          <a:p>
+            <a:pPr marL="285840" indent="-285480">
+              <a:lnSpc>
+                <a:spcPct val="100000"/>
+              </a:lnSpc>
+            </a:pPr>
+            <a:r>
+              <a:rPr lang="en-US" sz="4400" b="1" strike="noStrike" spc="-1">
+                <a:solidFill>
+                  <a:srgbClr val="2E75B6"/>
+                </a:solidFill>
+                <a:latin typeface="Calibri"/>
+              </a:rPr>
+              <a:t>Resources</a:t>
+            </a:r>
+            <a:endParaRPr lang="en-US" sz="4400" b="0" strike="noStrike" spc="-1">
+              <a:solidFill>
+                <a:srgbClr val="000000"/>
+              </a:solidFill>
+              <a:latin typeface="Arial"/>
+            </a:endParaRPr>
+          </a:p>
+        </p:txBody>
+      </p:sp>
+      <p:sp>
+        <p:nvSpPr>
+          <p:cNvPr id="139" name="TextShape 3"/>
+          <p:cNvSpPr txBox="1"/>
+          <p:nvPr/>
+        </p:nvSpPr>
+        <p:spPr>
+          <a:xfrm>
+            <a:off x="5678640" y="6409800"/>
+            <a:ext cx="1375200" cy="364680"/>
+          </a:xfrm>
+          <a:prstGeom prst="rect">
+            <a:avLst/>
+          </a:prstGeom>
+          <a:noFill/>
+          <a:ln>
+            <a:noFill/>
+          </a:ln>
+        </p:spPr>
+        <p:txBody>
+          <a:bodyPr anchor="ctr">
+            <a:noAutofit/>
+          </a:bodyPr>
+          <a:lstStyle/>
+          <a:p>
+            <a:pPr>
+              <a:lnSpc>
+                <a:spcPct val="100000"/>
+              </a:lnSpc>
+            </a:pPr>
+            <a:fld id="{96DF9C7D-5E38-486E-8788-46E53B4540D2}" type="datetime1">
+              <a:rPr lang="en-US" sz="1200" b="0" strike="noStrike" spc="-1">
+                <a:solidFill>
+                  <a:srgbClr val="8B8B8B"/>
+                </a:solidFill>
+                <a:latin typeface="Calibri"/>
+              </a:rPr>
+              <a:t>3/26/2025</a:t>
+            </a:fld>
+            <a:endParaRPr lang="en-US" sz="1200" b="0" strike="noStrike" spc="-1">
+              <a:latin typeface="Times New Roman"/>
+            </a:endParaRPr>
+          </a:p>
+        </p:txBody>
+      </p:sp>
+      <p:sp>
+        <p:nvSpPr>
+          <p:cNvPr id="140" name="TextShape 4"/>
+          <p:cNvSpPr txBox="1"/>
+          <p:nvPr/>
+        </p:nvSpPr>
+        <p:spPr>
+          <a:xfrm>
+            <a:off x="838080" y="6396480"/>
+            <a:ext cx="964440" cy="364680"/>
+          </a:xfrm>
+          <a:prstGeom prst="rect">
+            <a:avLst/>
+          </a:prstGeom>
+          <a:noFill/>
+          <a:ln>
+            <a:noFill/>
+          </a:ln>
+        </p:spPr>
+        <p:txBody>
+          <a:bodyPr anchor="ctr">
+            <a:noAutofit/>
+          </a:bodyPr>
+          <a:lstStyle/>
+          <a:p>
+            <a:pPr>
+              <a:lnSpc>
+                <a:spcPct val="100000"/>
+              </a:lnSpc>
+            </a:pPr>
+            <a:fld id="{DDC9E873-F36C-4741-A928-0EF646AA7E33}" type="slidenum">
+              <a:rPr lang="en-US" sz="1200" b="0" strike="noStrike" spc="-1">
+                <a:solidFill>
+                  <a:srgbClr val="8B8B8B"/>
+                </a:solidFill>
+                <a:latin typeface="Calibri"/>
+              </a:rPr>
+              <a:t>30</a:t>
+            </a:fld>
+            <a:endParaRPr lang="en-US" sz="1200" b="0" strike="noStrike" spc="-1">
+              <a:latin typeface="Times New Roman"/>
+            </a:endParaRPr>
+          </a:p>
+        </p:txBody>
+      </p:sp>
+    </p:spTree>
+  </p:cSld>
+  <p:clrMapOvr>
+    <a:masterClrMapping/>
+  </p:clrMapOvr>
+</p:sld>
+</file>
+
 <file path=ppt/slides/slide4.xml><?xml version="1.0" encoding="utf-8"?>
 <p:sld xmlns:a="http://schemas.openxmlformats.org/drawingml/2006/main" xmlns:r="http://schemas.openxmlformats.org/officeDocument/2006/relationships" xmlns:p="http://schemas.openxmlformats.org/presentationml/2006/main">
   <p:cSld>
@@ -28398,7 +28429,7 @@
                 </a:solidFill>
                 <a:latin typeface="Calibri"/>
               </a:rPr>
-              <a:t>1/10/2024</a:t>
+              <a:t>3/26/2025</a:t>
             </a:fld>
             <a:endParaRPr lang="en-US" sz="1200" b="0" strike="noStrike" spc="-1">
               <a:latin typeface="Times New Roman"/>
@@ -28874,7 +28905,7 @@
                 </a:solidFill>
                 <a:latin typeface="Calibri"/>
               </a:rPr>
-              <a:t>1/10/2024</a:t>
+              <a:t>3/26/2025</a:t>
             </a:fld>
             <a:endParaRPr lang="en-US" sz="1200" b="0" strike="noStrike" spc="-1">
               <a:latin typeface="Times New Roman"/>
@@ -32338,7 +32369,7 @@
                 </a:solidFill>
                 <a:latin typeface="Calibri"/>
               </a:rPr>
-              <a:t>1/10/2024</a:t>
+              <a:t>3/26/2025</a:t>
             </a:fld>
             <a:endParaRPr lang="en-US" sz="1200" b="0" strike="noStrike" spc="-1">
               <a:latin typeface="Times New Roman"/>
@@ -32812,7 +32843,7 @@
                 </a:solidFill>
                 <a:latin typeface="Calibri"/>
               </a:rPr>
-              <a:t>1/10/2024</a:t>
+              <a:t>3/26/2025</a:t>
             </a:fld>
             <a:endParaRPr lang="en-US" sz="1200" b="0" strike="noStrike" spc="-1">
               <a:latin typeface="Times New Roman"/>

</xml_diff>